<commit_message>
fix: critério anti-vazamento — separa modelo preditivo de explicativo
Trata como vazamento todas as variáveis medidas no próprio ano (n_os_ano,
n_os_preventivas_ano, n_sistemas_vmrs, km_rodado_ano, delta_km_medio_os,
km_acumulado_fim_ano, vmrs_predominante), além das derivadas de Y.

- Modelo preditivo usa só atributos do ativo + histórico defasado
- Melhor preditivo: Random Forest R²≈0,50 (GB 0,48); linear 0,08
- Modelo com variáveis do ano (R²≈0,69) mantido só como sensibilidade explicativa
- Importância preditiva: unit_subtype, custo_acum, idade, km defasado, região
- Notebook, tabelas, figuras, README e deck atualizados

Co-authored-by: Cursor <cursoragent@cursor.com>
</commit_message>
<xml_diff>
--- a/nova_versao_jeison/apresentacao/Apresentacao_QuatroNorte_anual.pptx
+++ b/nova_versao_jeison/apresentacao/Apresentacao_QuatroNorte_anual.pptx
@@ -31804,43 +31804,180 @@
           </a:p>
         </p:txBody>
       </p:sp>
-      <p:pic>
-        <p:nvPicPr>
-          <p:cNvPr id="5" name="Image 0" descr="preencoded.png"/>
-          <p:cNvPicPr>
-            <a:picLocks noChangeAspect="1"/>
-          </p:cNvPicPr>
-          <p:nvPr/>
-        </p:nvPicPr>
-        <p:blipFill>
-          <a:blip r:embed="rId3"/>
-          <a:srcRect/>
-          <a:stretch/>
-        </p:blipFill>
-        <p:spPr>
-          <a:xfrm>
-            <a:off x="2760583" y="2091690"/>
-            <a:ext cx="8212455" cy="7299960"/>
-          </a:xfrm>
-          <a:prstGeom prst="rect">
-            <a:avLst/>
-          </a:prstGeom>
-        </p:spPr>
-      </p:pic>
-      <p:sp>
-        <p:nvSpPr>
-          <p:cNvPr id="6" name="Shape 3"/>
-          <p:cNvSpPr/>
-          <p:nvPr/>
-        </p:nvSpPr>
-        <p:spPr>
-          <a:xfrm>
-            <a:off x="13124021" y="3564255"/>
-            <a:ext cx="4211479" cy="1108710"/>
+      <p:sp>
+        <p:nvSpPr>
+          <p:cNvPr id="8" name="Text 5"/>
+          <p:cNvSpPr/>
+          <p:nvPr/>
+        </p:nvSpPr>
+        <p:spPr>
+          <a:xfrm>
+            <a:off x="13417391" y="4158615"/>
+            <a:ext cx="3987213" cy="297180"/>
+          </a:xfrm>
+          <a:prstGeom prst="rect">
+            <a:avLst/>
+          </a:prstGeom>
+          <a:noFill/>
+          <a:ln/>
+        </p:spPr>
+        <p:txBody>
+          <a:bodyPr wrap="square" lIns="25400" tIns="25400" rIns="25400" bIns="25400" rtlCol="0" anchor="t">
+            <a:normAutofit/>
+          </a:bodyPr>
+          <a:lstStyle/>
+          <a:p>
+            <a:pPr marL="0" indent="0" algn="l">
+              <a:buNone/>
+            </a:pPr>
+            <a:r>
+              <a:rPr lang="en-US" sz="1575" dirty="0">
+                <a:solidFill>
+                  <a:srgbClr val="8FA1AE"/>
+                </a:solidFill>
+                <a:latin typeface="Arial" pitchFamily="34" charset="0"/>
+                <a:ea typeface="Arial" pitchFamily="34" charset="-122"/>
+                <a:cs typeface="Arial" pitchFamily="34" charset="-120"/>
+              </a:rPr>
+              <a:t>ranking ≠ seleção</a:t>
+            </a:r>
+            <a:endParaRPr lang="en-US" sz="1575" dirty="0"/>
+          </a:p>
+        </p:txBody>
+      </p:sp>
+      <p:sp>
+        <p:nvSpPr>
+          <p:cNvPr id="9" name="Shape 6"/>
+          <p:cNvSpPr/>
+          <p:nvPr/>
+        </p:nvSpPr>
+        <p:spPr>
+          <a:xfrm>
+            <a:off x="13124021" y="4844415"/>
+            <a:ext cx="4211479" cy="1581150"/>
           </a:xfrm>
           <a:prstGeom prst="roundRect">
             <a:avLst>
-              <a:gd name="adj" fmla="val 12027"/>
+              <a:gd name="adj" fmla="val 8434"/>
+            </a:avLst>
+          </a:prstGeom>
+          <a:solidFill>
+            <a:srgbClr val="0E211E"/>
+          </a:solidFill>
+          <a:ln w="7620">
+            <a:solidFill>
+              <a:srgbClr val="1C3B34"/>
+            </a:solidFill>
+            <a:prstDash val="solid"/>
+          </a:ln>
+        </p:spPr>
+        <p:txBody>
+          <a:bodyPr/>
+          <a:lstStyle/>
+          <a:p>
+            <a:r>
+              <a:t>ranking ≠ seleção</a:t>
+            </a:r>
+            <a:endParaRPr lang="pt-BR"/>
+          </a:p>
+        </p:txBody>
+      </p:sp>
+      <p:sp>
+        <p:nvSpPr>
+          <p:cNvPr id="10" name="Text 7"/>
+          <p:cNvSpPr/>
+          <p:nvPr/>
+        </p:nvSpPr>
+        <p:spPr>
+          <a:xfrm>
+            <a:off x="13417391" y="5099685"/>
+            <a:ext cx="3987213" cy="274320"/>
+          </a:xfrm>
+          <a:prstGeom prst="rect">
+            <a:avLst/>
+          </a:prstGeom>
+          <a:noFill/>
+          <a:ln/>
+        </p:spPr>
+        <p:txBody>
+          <a:bodyPr wrap="square" lIns="25400" tIns="25400" rIns="25400" bIns="25400" rtlCol="0" anchor="t">
+            <a:normAutofit/>
+          </a:bodyPr>
+          <a:lstStyle/>
+          <a:p>
+            <a:pPr marL="0" indent="0" algn="l">
+              <a:buNone/>
+            </a:pPr>
+            <a:r>
+              <a:rPr lang="en-US" sz="1650" b="1" dirty="0">
+                <a:solidFill>
+                  <a:srgbClr val="3FE0CE"/>
+                </a:solidFill>
+                <a:latin typeface="Courier New" pitchFamily="34" charset="0"/>
+                <a:ea typeface="Courier New" pitchFamily="34" charset="-122"/>
+                <a:cs typeface="Courier New" pitchFamily="34" charset="-120"/>
+              </a:rPr>
+              <a:t>ranking ≠ seleção</a:t>
+            </a:r>
+            <a:endParaRPr lang="en-US" sz="1650" dirty="0"/>
+          </a:p>
+        </p:txBody>
+      </p:sp>
+      <p:sp>
+        <p:nvSpPr>
+          <p:cNvPr id="11" name="Text 8"/>
+          <p:cNvSpPr/>
+          <p:nvPr/>
+        </p:nvSpPr>
+        <p:spPr>
+          <a:xfrm>
+            <a:off x="13417391" y="5393055"/>
+            <a:ext cx="3733481" cy="815340"/>
+          </a:xfrm>
+          <a:prstGeom prst="rect">
+            <a:avLst/>
+          </a:prstGeom>
+          <a:noFill/>
+          <a:ln/>
+        </p:spPr>
+        <p:txBody>
+          <a:bodyPr wrap="square" lIns="25400" tIns="25400" rIns="25400" bIns="25400" rtlCol="0" anchor="t">
+            <a:normAutofit/>
+          </a:bodyPr>
+          <a:lstStyle/>
+          <a:p>
+            <a:pPr marL="0" indent="0" algn="l">
+              <a:buNone/>
+            </a:pPr>
+            <a:r>
+              <a:rPr lang="en-US" sz="1575" dirty="0">
+                <a:solidFill>
+                  <a:srgbClr val="8FA1AE"/>
+                </a:solidFill>
+                <a:latin typeface="Arial" pitchFamily="34" charset="0"/>
+                <a:ea typeface="Arial" pitchFamily="34" charset="-122"/>
+                <a:cs typeface="Arial" pitchFamily="34" charset="-120"/>
+              </a:rPr>
+              <a:t>as mais associadas são do próprio ano → saem por vazamento</a:t>
+            </a:r>
+            <a:endParaRPr lang="en-US" sz="1575" dirty="0"/>
+          </a:p>
+        </p:txBody>
+      </p:sp>
+      <p:sp>
+        <p:nvSpPr>
+          <p:cNvPr id="12" name="Shape 9"/>
+          <p:cNvSpPr/>
+          <p:nvPr/>
+        </p:nvSpPr>
+        <p:spPr>
+          <a:xfrm>
+            <a:off x="13124021" y="6597015"/>
+            <a:ext cx="4211479" cy="1322070"/>
+          </a:xfrm>
+          <a:prstGeom prst="roundRect">
+            <a:avLst>
+              <a:gd name="adj" fmla="val 10086"/>
             </a:avLst>
           </a:prstGeom>
           <a:solidFill>
@@ -31857,61 +31994,64 @@
           <a:bodyPr/>
           <a:lstStyle/>
           <a:p>
+            <a:r>
+              <a:t>preditores válidos</a:t>
+            </a:r>
             <a:endParaRPr lang="pt-BR"/>
           </a:p>
         </p:txBody>
       </p:sp>
       <p:sp>
         <p:nvSpPr>
-          <p:cNvPr id="7" name="Text 4"/>
-          <p:cNvSpPr/>
-          <p:nvPr/>
-        </p:nvSpPr>
-        <p:spPr>
-          <a:xfrm>
-            <a:off x="13417391" y="3819525"/>
-            <a:ext cx="3987213" cy="320040"/>
-          </a:xfrm>
-          <a:prstGeom prst="rect">
-            <a:avLst/>
-          </a:prstGeom>
-          <a:noFill/>
-          <a:ln/>
-        </p:spPr>
-        <p:txBody>
-          <a:bodyPr wrap="square" lIns="25400" tIns="25400" rIns="25400" bIns="25400" rtlCol="0" anchor="t">
-            <a:normAutofit/>
-          </a:bodyPr>
-          <a:lstStyle/>
-          <a:p>
-            <a:pPr marL="0" indent="0" algn="l">
-              <a:buNone/>
-            </a:pPr>
-            <a:r>
-              <a:rPr lang="en-US" sz="1950" b="1" dirty="0">
-                <a:solidFill>
-                  <a:srgbClr val="FFB65C"/>
+          <p:cNvPr id="13" name="Text 10"/>
+          <p:cNvSpPr/>
+          <p:nvPr/>
+        </p:nvSpPr>
+        <p:spPr>
+          <a:xfrm>
+            <a:off x="13417391" y="6852285"/>
+            <a:ext cx="3987213" cy="274320"/>
+          </a:xfrm>
+          <a:prstGeom prst="rect">
+            <a:avLst/>
+          </a:prstGeom>
+          <a:noFill/>
+          <a:ln/>
+        </p:spPr>
+        <p:txBody>
+          <a:bodyPr wrap="square" lIns="25400" tIns="25400" rIns="25400" bIns="25400" rtlCol="0" anchor="t">
+            <a:normAutofit/>
+          </a:bodyPr>
+          <a:lstStyle/>
+          <a:p>
+            <a:pPr marL="0" indent="0" algn="l">
+              <a:buNone/>
+            </a:pPr>
+            <a:r>
+              <a:rPr lang="en-US" sz="1650" b="1" dirty="0">
+                <a:solidFill>
+                  <a:srgbClr val="F4F9F8"/>
                 </a:solidFill>
                 <a:latin typeface="Courier New" pitchFamily="34" charset="0"/>
                 <a:ea typeface="Courier New" pitchFamily="34" charset="-122"/>
                 <a:cs typeface="Courier New" pitchFamily="34" charset="-120"/>
               </a:rPr>
-              <a:t>máx ρ = 0,75</a:t>
-            </a:r>
-            <a:endParaRPr lang="en-US" sz="1950" dirty="0"/>
-          </a:p>
-        </p:txBody>
-      </p:sp>
-      <p:sp>
-        <p:nvSpPr>
-          <p:cNvPr id="8" name="Text 5"/>
-          <p:cNvSpPr/>
-          <p:nvPr/>
-        </p:nvSpPr>
-        <p:spPr>
-          <a:xfrm>
-            <a:off x="13417391" y="4158615"/>
-            <a:ext cx="3987213" cy="297180"/>
+              <a:t>preditores válidos</a:t>
+            </a:r>
+            <a:endParaRPr lang="en-US" sz="1650" dirty="0"/>
+          </a:p>
+        </p:txBody>
+      </p:sp>
+      <p:sp>
+        <p:nvSpPr>
+          <p:cNvPr id="14" name="Text 11"/>
+          <p:cNvSpPr/>
+          <p:nvPr/>
+        </p:nvSpPr>
+        <p:spPr>
+          <a:xfrm>
+            <a:off x="13417391" y="7145655"/>
+            <a:ext cx="3733481" cy="556260"/>
           </a:xfrm>
           <a:prstGeom prst="rect">
             <a:avLst/>
@@ -31937,244 +32077,84 @@
                 <a:ea typeface="Arial" pitchFamily="34" charset="-122"/>
                 <a:cs typeface="Arial" pitchFamily="34" charset="-120"/>
               </a:rPr>
-              <a:t>n_os_ano lidera o ranking</a:t>
+              <a:t>custo_acum · custo_ano_anterior · idade · unit_subtype · km defasado</a:t>
             </a:r>
             <a:endParaRPr lang="en-US" sz="1575" dirty="0"/>
           </a:p>
         </p:txBody>
       </p:sp>
-      <p:sp>
-        <p:nvSpPr>
-          <p:cNvPr id="9" name="Shape 6"/>
-          <p:cNvSpPr/>
-          <p:nvPr/>
-        </p:nvSpPr>
-        <p:spPr>
-          <a:xfrm>
-            <a:off x="13124021" y="4844415"/>
-            <a:ext cx="4211479" cy="1581150"/>
-          </a:xfrm>
-          <a:prstGeom prst="roundRect">
-            <a:avLst>
-              <a:gd name="adj" fmla="val 8434"/>
-            </a:avLst>
-          </a:prstGeom>
-          <a:solidFill>
-            <a:srgbClr val="0E211E"/>
-          </a:solidFill>
-          <a:ln w="7620">
-            <a:solidFill>
-              <a:srgbClr val="1C3B34"/>
-            </a:solidFill>
-            <a:prstDash val="solid"/>
-          </a:ln>
-        </p:spPr>
-        <p:txBody>
-          <a:bodyPr/>
-          <a:lstStyle/>
-          <a:p>
-            <a:endParaRPr lang="pt-BR"/>
-          </a:p>
-        </p:txBody>
-      </p:sp>
-      <p:sp>
-        <p:nvSpPr>
-          <p:cNvPr id="10" name="Text 7"/>
-          <p:cNvSpPr/>
-          <p:nvPr/>
-        </p:nvSpPr>
-        <p:spPr>
-          <a:xfrm>
-            <a:off x="13417391" y="5099685"/>
-            <a:ext cx="3987213" cy="274320"/>
-          </a:xfrm>
-          <a:prstGeom prst="rect">
-            <a:avLst/>
-          </a:prstGeom>
-          <a:noFill/>
-          <a:ln/>
-        </p:spPr>
-        <p:txBody>
-          <a:bodyPr wrap="square" lIns="25400" tIns="25400" rIns="25400" bIns="25400" rtlCol="0" anchor="t">
-            <a:normAutofit/>
-          </a:bodyPr>
-          <a:lstStyle/>
-          <a:p>
-            <a:pPr marL="0" indent="0" algn="l">
-              <a:buNone/>
-            </a:pPr>
-            <a:r>
-              <a:rPr lang="en-US" sz="1650" b="1" dirty="0">
-                <a:solidFill>
-                  <a:srgbClr val="3FE0CE"/>
-                </a:solidFill>
-                <a:latin typeface="Courier New" pitchFamily="34" charset="0"/>
-                <a:ea typeface="Courier New" pitchFamily="34" charset="-122"/>
-                <a:cs typeface="Courier New" pitchFamily="34" charset="-120"/>
-              </a:rPr>
-              <a:t>histórico domina</a:t>
-            </a:r>
-            <a:endParaRPr lang="en-US" sz="1650" dirty="0"/>
-          </a:p>
-        </p:txBody>
-      </p:sp>
-      <p:sp>
-        <p:nvSpPr>
-          <p:cNvPr id="11" name="Text 8"/>
-          <p:cNvSpPr/>
-          <p:nvPr/>
-        </p:nvSpPr>
-        <p:spPr>
-          <a:xfrm>
-            <a:off x="13417391" y="5393055"/>
-            <a:ext cx="3733481" cy="815340"/>
-          </a:xfrm>
-          <a:prstGeom prst="rect">
-            <a:avLst/>
-          </a:prstGeom>
-          <a:noFill/>
-          <a:ln/>
-        </p:spPr>
-        <p:txBody>
-          <a:bodyPr wrap="square" lIns="25400" tIns="25400" rIns="25400" bIns="25400" rtlCol="0" anchor="t">
-            <a:normAutofit/>
-          </a:bodyPr>
-          <a:lstStyle/>
-          <a:p>
-            <a:pPr marL="0" indent="0" algn="l">
-              <a:buNone/>
-            </a:pPr>
-            <a:r>
-              <a:rPr lang="en-US" sz="1575" dirty="0">
-                <a:solidFill>
-                  <a:srgbClr val="8FA1AE"/>
-                </a:solidFill>
-                <a:latin typeface="Arial" pitchFamily="34" charset="0"/>
-                <a:ea typeface="Arial" pitchFamily="34" charset="-122"/>
-                <a:cs typeface="Arial" pitchFamily="34" charset="-120"/>
-              </a:rPr>
-              <a:t>n_os_ano · custo_ano_anterior · custo_acum · intervalo_medio_os — suporte à H4</a:t>
-            </a:r>
-            <a:endParaRPr lang="en-US" sz="1575" dirty="0"/>
-          </a:p>
-        </p:txBody>
-      </p:sp>
-      <p:sp>
-        <p:nvSpPr>
-          <p:cNvPr id="12" name="Shape 9"/>
-          <p:cNvSpPr/>
-          <p:nvPr/>
-        </p:nvSpPr>
-        <p:spPr>
-          <a:xfrm>
-            <a:off x="13124021" y="6597015"/>
-            <a:ext cx="4211479" cy="1322070"/>
-          </a:xfrm>
-          <a:prstGeom prst="roundRect">
-            <a:avLst>
-              <a:gd name="adj" fmla="val 10086"/>
-            </a:avLst>
-          </a:prstGeom>
-          <a:solidFill>
-            <a:srgbClr val="101B26"/>
-          </a:solidFill>
-          <a:ln w="7620">
-            <a:solidFill>
-              <a:srgbClr val="223243"/>
-            </a:solidFill>
-            <a:prstDash val="solid"/>
-          </a:ln>
-        </p:spPr>
-        <p:txBody>
-          <a:bodyPr/>
-          <a:lstStyle/>
-          <a:p>
-            <a:endParaRPr lang="pt-BR"/>
-          </a:p>
-        </p:txBody>
-      </p:sp>
-      <p:sp>
-        <p:nvSpPr>
-          <p:cNvPr id="13" name="Text 10"/>
-          <p:cNvSpPr/>
-          <p:nvPr/>
-        </p:nvSpPr>
-        <p:spPr>
-          <a:xfrm>
-            <a:off x="13417391" y="6852285"/>
-            <a:ext cx="3987213" cy="274320"/>
-          </a:xfrm>
-          <a:prstGeom prst="rect">
-            <a:avLst/>
-          </a:prstGeom>
-          <a:noFill/>
-          <a:ln/>
-        </p:spPr>
-        <p:txBody>
-          <a:bodyPr wrap="square" lIns="25400" tIns="25400" rIns="25400" bIns="25400" rtlCol="0" anchor="t">
-            <a:normAutofit/>
-          </a:bodyPr>
-          <a:lstStyle/>
-          <a:p>
-            <a:pPr marL="0" indent="0" algn="l">
-              <a:buNone/>
-            </a:pPr>
-            <a:r>
-              <a:rPr lang="en-US" sz="1650" b="1" dirty="0">
-                <a:solidFill>
-                  <a:srgbClr val="F4F9F8"/>
-                </a:solidFill>
-                <a:latin typeface="Courier New" pitchFamily="34" charset="0"/>
-                <a:ea typeface="Courier New" pitchFamily="34" charset="-122"/>
-                <a:cs typeface="Courier New" pitchFamily="34" charset="-120"/>
-              </a:rPr>
-              <a:t>interações</a:t>
-            </a:r>
-            <a:endParaRPr lang="en-US" sz="1650" dirty="0"/>
-          </a:p>
-        </p:txBody>
-      </p:sp>
-      <p:sp>
-        <p:nvSpPr>
-          <p:cNvPr id="14" name="Text 11"/>
-          <p:cNvSpPr/>
-          <p:nvPr/>
-        </p:nvSpPr>
-        <p:spPr>
-          <a:xfrm>
-            <a:off x="13417391" y="7145655"/>
-            <a:ext cx="3733481" cy="556260"/>
-          </a:xfrm>
-          <a:prstGeom prst="rect">
-            <a:avLst/>
-          </a:prstGeom>
-          <a:noFill/>
-          <a:ln/>
-        </p:spPr>
-        <p:txBody>
-          <a:bodyPr wrap="square" lIns="25400" tIns="25400" rIns="25400" bIns="25400" rtlCol="0" anchor="t">
-            <a:normAutofit/>
-          </a:bodyPr>
-          <a:lstStyle/>
-          <a:p>
-            <a:pPr marL="0" indent="0" algn="l">
-              <a:buNone/>
-            </a:pPr>
-            <a:r>
-              <a:rPr lang="en-US" sz="1575" dirty="0">
-                <a:solidFill>
-                  <a:srgbClr val="8FA1AE"/>
-                </a:solidFill>
-                <a:latin typeface="Arial" pitchFamily="34" charset="0"/>
-                <a:ea typeface="Arial" pitchFamily="34" charset="-122"/>
-                <a:cs typeface="Arial" pitchFamily="34" charset="-120"/>
-              </a:rPr>
-              <a:t>o ganho preditivo vem de combinações — favorece árvores/ensembles</a:t>
-            </a:r>
-            <a:endParaRPr lang="en-US" sz="1575" dirty="0"/>
-          </a:p>
-        </p:txBody>
-      </p:sp>
+      <p:pic>
+        <p:nvPicPr>
+          <p:cNvPr id="15" name="Picture 14" descr="06_ranking_associacao.png"/>
+          <p:cNvPicPr>
+            <a:picLocks noChangeAspect="1"/>
+          </p:cNvPicPr>
+          <p:nvPr/>
+        </p:nvPicPr>
+        <p:blipFill>
+          <a:blip r:embed="rId4"/>
+          <a:stretch>
+            <a:fillRect/>
+          </a:stretch>
+        </p:blipFill>
+        <p:spPr>
+          <a:xfrm>
+            <a:off x="2761488" y="2093976"/>
+            <a:ext cx="8211312" cy="7296912"/>
+          </a:xfrm>
+          <a:prstGeom prst="rect">
+            <a:avLst/>
+          </a:prstGeom>
+        </p:spPr>
+      </p:pic>
+      <p:pic>
+        <p:nvPicPr>
+          <p:cNvPr id="16" name="Picture 15" descr="image.png"/>
+          <p:cNvPicPr>
+            <a:picLocks noChangeAspect="1"/>
+          </p:cNvPicPr>
+          <p:nvPr/>
+        </p:nvPicPr>
+        <p:blipFill>
+          <a:blip r:embed="rId4"/>
+          <a:stretch>
+            <a:fillRect/>
+          </a:stretch>
+        </p:blipFill>
+        <p:spPr>
+          <a:xfrm>
+            <a:off x="2761488" y="2093976"/>
+            <a:ext cx="8211312" cy="7296912"/>
+          </a:xfrm>
+          <a:prstGeom prst="rect">
+            <a:avLst/>
+          </a:prstGeom>
+        </p:spPr>
+      </p:pic>
+      <p:pic>
+        <p:nvPicPr>
+          <p:cNvPr id="17" name="Picture 16" descr="image.png"/>
+          <p:cNvPicPr>
+            <a:picLocks noChangeAspect="1"/>
+          </p:cNvPicPr>
+          <p:nvPr/>
+        </p:nvPicPr>
+        <p:blipFill>
+          <a:blip r:embed="rId4"/>
+          <a:stretch>
+            <a:fillRect/>
+          </a:stretch>
+        </p:blipFill>
+        <p:spPr>
+          <a:xfrm>
+            <a:off x="2761488" y="2093976"/>
+            <a:ext cx="8211312" cy="7296912"/>
+          </a:xfrm>
+          <a:prstGeom prst="rect">
+            <a:avLst/>
+          </a:prstGeom>
+        </p:spPr>
+      </p:pic>
     </p:spTree>
   </p:cSld>
   <p:clrMapOvr>
@@ -34535,7 +34515,7 @@
                 <a:ea typeface="Arial" pitchFamily="34" charset="-122"/>
                 <a:cs typeface="Arial" pitchFamily="34" charset="-120"/>
               </a:rPr>
-              <a:t>n_os_ano ρ 0,75; várias variáveis acima de 0,4 — histórico e uso concentram o sinal</a:t>
+              <a:t>as maiores correlações são do próprio ano (vazamento) e saem; o sinal preditivo vem do histórico defasado e do tipo/uso</a:t>
             </a:r>
             <a:endParaRPr lang="en-US" sz="1800" dirty="0"/>
           </a:p>
@@ -35620,7 +35600,7 @@
                 <a:ea typeface="Arial" pitchFamily="34" charset="-122"/>
                 <a:cs typeface="Arial" pitchFamily="34" charset="-120"/>
               </a:rPr>
-              <a:t>Random Forest</a:t>
+              <a:t>Random Forest ◀ recomendado</a:t>
             </a:r>
             <a:endParaRPr lang="en-US" sz="1725" dirty="0"/>
           </a:p>
@@ -35664,7 +35644,7 @@
                 <a:ea typeface="Arial" pitchFamily="34" charset="-122"/>
                 <a:cs typeface="Arial" pitchFamily="34" charset="-120"/>
               </a:rPr>
-              <a:t>Gradient Boosting ◀ recomendado</a:t>
+              <a:t>Gradient Boosting</a:t>
             </a:r>
             <a:endParaRPr lang="en-US" sz="1725" dirty="0"/>
           </a:p>
@@ -35752,7 +35732,7 @@
                 <a:ea typeface="Arial" pitchFamily="34" charset="-122"/>
                 <a:cs typeface="Arial" pitchFamily="34" charset="-120"/>
               </a:rPr>
-              <a:t>Análise de sensibilidade: modelo sem n_os_ano, para medir a dependência do preditor dominante</a:t>
+              <a:t>Critério anti-vazamento: variáveis do próprio ano ficam fora do modelo; versão explicativa só como sensibilidade</a:t>
             </a:r>
             <a:r>
               <a:rPr lang="en-US" sz="1575" dirty="0">
@@ -36379,7 +36359,7 @@
                 <a:ea typeface="Courier New" pitchFamily="34" charset="-122"/>
                 <a:cs typeface="Courier New" pitchFamily="34" charset="-120"/>
               </a:rPr>
-              <a:t>gradient_boosting ◀</a:t>
+              <a:t>random_forest ◀</a:t>
             </a:r>
             <a:endParaRPr lang="en-US" sz="1650" dirty="0"/>
           </a:p>
@@ -36420,7 +36400,7 @@
                 <a:ea typeface="Courier New" pitchFamily="34" charset="-122"/>
                 <a:cs typeface="Courier New" pitchFamily="34" charset="-120"/>
               </a:rPr>
-              <a:t>0,685</a:t>
+              <a:t>0,498</a:t>
             </a:r>
             <a:endParaRPr lang="en-US" sz="1650" dirty="0"/>
           </a:p>
@@ -36461,7 +36441,7 @@
                 <a:ea typeface="Courier New" pitchFamily="34" charset="-122"/>
                 <a:cs typeface="Courier New" pitchFamily="34" charset="-120"/>
               </a:rPr>
-              <a:t>1.501</a:t>
+              <a:t>1.894</a:t>
             </a:r>
             <a:endParaRPr lang="en-US" sz="1650" dirty="0"/>
           </a:p>
@@ -36502,7 +36482,7 @@
                 <a:ea typeface="Courier New" pitchFamily="34" charset="-122"/>
                 <a:cs typeface="Courier New" pitchFamily="34" charset="-120"/>
               </a:rPr>
-              <a:t>839</a:t>
+              <a:t>1.149</a:t>
             </a:r>
             <a:endParaRPr lang="en-US" sz="1650" dirty="0"/>
           </a:p>
@@ -36577,7 +36557,7 @@
                 <a:ea typeface="Courier New" pitchFamily="34" charset="-122"/>
                 <a:cs typeface="Courier New" pitchFamily="34" charset="-120"/>
               </a:rPr>
-              <a:t>random_forest</a:t>
+              <a:t>gradient_boosting</a:t>
             </a:r>
             <a:endParaRPr lang="en-US" sz="1575" dirty="0"/>
           </a:p>
@@ -36618,7 +36598,7 @@
                 <a:ea typeface="Courier New" pitchFamily="34" charset="-122"/>
                 <a:cs typeface="Courier New" pitchFamily="34" charset="-120"/>
               </a:rPr>
-              <a:t>0,674</a:t>
+              <a:t>0,484</a:t>
             </a:r>
             <a:endParaRPr lang="en-US" sz="1575" dirty="0"/>
           </a:p>
@@ -36659,7 +36639,7 @@
                 <a:ea typeface="Courier New" pitchFamily="34" charset="-122"/>
                 <a:cs typeface="Courier New" pitchFamily="34" charset="-120"/>
               </a:rPr>
-              <a:t>1.527</a:t>
+              <a:t>1.921</a:t>
             </a:r>
             <a:endParaRPr lang="en-US" sz="1575" dirty="0"/>
           </a:p>
@@ -36700,7 +36680,7 @@
                 <a:ea typeface="Courier New" pitchFamily="34" charset="-122"/>
                 <a:cs typeface="Courier New" pitchFamily="34" charset="-120"/>
               </a:rPr>
-              <a:t>865</a:t>
+              <a:t>1.130</a:t>
             </a:r>
             <a:endParaRPr lang="en-US" sz="1575" dirty="0"/>
           </a:p>
@@ -36775,7 +36755,7 @@
                 <a:ea typeface="Courier New" pitchFamily="34" charset="-122"/>
                 <a:cs typeface="Courier New" pitchFamily="34" charset="-120"/>
               </a:rPr>
-              <a:t>gb · sem n_os_ano</a:t>
+              <a:t>regressão linear (log)</a:t>
             </a:r>
             <a:endParaRPr lang="en-US" sz="1575" dirty="0"/>
           </a:p>
@@ -36816,7 +36796,7 @@
                 <a:ea typeface="Courier New" pitchFamily="34" charset="-122"/>
                 <a:cs typeface="Courier New" pitchFamily="34" charset="-120"/>
               </a:rPr>
-              <a:t>0,640</a:t>
+              <a:t>0,082</a:t>
             </a:r>
             <a:endParaRPr lang="en-US" sz="1575" dirty="0"/>
           </a:p>
@@ -36857,7 +36837,7 @@
                 <a:ea typeface="Courier New" pitchFamily="34" charset="-122"/>
                 <a:cs typeface="Courier New" pitchFamily="34" charset="-120"/>
               </a:rPr>
-              <a:t>1.604</a:t>
+              <a:t>2.562</a:t>
             </a:r>
             <a:endParaRPr lang="en-US" sz="1575" dirty="0"/>
           </a:p>
@@ -36898,7 +36878,7 @@
                 <a:ea typeface="Courier New" pitchFamily="34" charset="-122"/>
                 <a:cs typeface="Courier New" pitchFamily="34" charset="-120"/>
               </a:rPr>
-              <a:t>901</a:t>
+              <a:t>1.253</a:t>
             </a:r>
             <a:endParaRPr lang="en-US" sz="1575" dirty="0"/>
           </a:p>
@@ -36973,7 +36953,7 @@
                 <a:ea typeface="Courier New" pitchFamily="34" charset="-122"/>
                 <a:cs typeface="Courier New" pitchFamily="34" charset="-120"/>
               </a:rPr>
-              <a:t>regressão linear (log)</a:t>
+              <a:t>gb · explicativo (c/ ano)</a:t>
             </a:r>
             <a:endParaRPr lang="en-US" sz="1575" dirty="0"/>
           </a:p>
@@ -37014,7 +36994,7 @@
                 <a:ea typeface="Courier New" pitchFamily="34" charset="-122"/>
                 <a:cs typeface="Courier New" pitchFamily="34" charset="-120"/>
               </a:rPr>
-              <a:t>−1,66</a:t>
+              <a:t>0,687</a:t>
             </a:r>
             <a:endParaRPr lang="en-US" sz="1575" dirty="0"/>
           </a:p>
@@ -37055,7 +37035,7 @@
                 <a:ea typeface="Courier New" pitchFamily="34" charset="-122"/>
                 <a:cs typeface="Courier New" pitchFamily="34" charset="-120"/>
               </a:rPr>
-              <a:t>4.360</a:t>
+              <a:t>1.497</a:t>
             </a:r>
             <a:endParaRPr lang="en-US" sz="1575" dirty="0"/>
           </a:p>
@@ -37096,7 +37076,7 @@
                 <a:ea typeface="Courier New" pitchFamily="34" charset="-122"/>
                 <a:cs typeface="Courier New" pitchFamily="34" charset="-120"/>
               </a:rPr>
-              <a:t>1.357</a:t>
+              <a:t>837</a:t>
             </a:r>
             <a:endParaRPr lang="en-US" sz="1575" dirty="0"/>
           </a:p>
@@ -37499,7 +37479,7 @@
                 <a:ea typeface="Arial" pitchFamily="34" charset="-122"/>
                 <a:cs typeface="Arial" pitchFamily="34" charset="-120"/>
               </a:rPr>
-              <a:t>R² ≈ 69%</a:t>
+              <a:t>R² ≈ 50%</a:t>
             </a:r>
             <a:endParaRPr lang="en-US" sz="3900" dirty="0"/>
           </a:p>
@@ -37543,7 +37523,7 @@
                 <a:ea typeface="Arial" pitchFamily="34" charset="-122"/>
                 <a:cs typeface="Arial" pitchFamily="34" charset="-120"/>
               </a:rPr>
-              <a:t>da variação anual do custo por carreta explicada pelo Gradient Boosting (WAPE 0,415)</a:t>
+              <a:t>da variação anual do custo por carreta explicada pelo modelo preditivo (Random Forest · WAPE 0,57)</a:t>
             </a:r>
             <a:r>
               <a:rPr lang="en-US" sz="1575" b="1" dirty="0">
@@ -37684,7 +37664,7 @@
                 <a:ea typeface="Arial" pitchFamily="34" charset="-122"/>
                 <a:cs typeface="Arial" pitchFamily="34" charset="-120"/>
               </a:rPr>
-              <a:t>n_os_ano domina; sem ela o R² ainda é 0,64 (idade, km, histórico, tipo e região)</a:t>
+              <a:t>custo acumulado, tipo da unidade, idade e km defasado; variáveis do próprio ano ficam fora por vazamento</a:t>
             </a:r>
             <a:endParaRPr lang="en-US" sz="1575" dirty="0"/>
           </a:p>
@@ -38438,7 +38418,7 @@
                 <a:ea typeface="Courier New" pitchFamily="34" charset="-122"/>
                 <a:cs typeface="Courier New" pitchFamily="34" charset="-120"/>
               </a:rPr>
-              <a:t>n_os_ano</a:t>
+              <a:t>unit_subtype</a:t>
             </a:r>
             <a:endParaRPr lang="en-US" sz="1650" dirty="0"/>
           </a:p>
@@ -38482,7 +38462,7 @@
         <p:spPr>
           <a:xfrm>
             <a:off x="5372100" y="3072765"/>
-            <a:ext cx="10782300" cy="323850"/>
+            <a:ext cx="10780776" cy="323850"/>
           </a:xfrm>
           <a:prstGeom prst="rect">
             <a:avLst/>
@@ -38535,7 +38515,7 @@
                 <a:ea typeface="Courier New" pitchFamily="34" charset="-122"/>
                 <a:cs typeface="Courier New" pitchFamily="34" charset="-120"/>
               </a:rPr>
-              <a:t>0,878</a:t>
+              <a:t>0,094</a:t>
             </a:r>
             <a:endParaRPr lang="en-US" sz="1500" dirty="0"/>
           </a:p>
@@ -38576,7 +38556,7 @@
                 <a:ea typeface="Courier New" pitchFamily="34" charset="-122"/>
                 <a:cs typeface="Courier New" pitchFamily="34" charset="-120"/>
               </a:rPr>
-              <a:t>vmrs_predominante</a:t>
+              <a:t>custo_acum</a:t>
             </a:r>
             <a:endParaRPr lang="en-US" sz="1650" dirty="0"/>
           </a:p>
@@ -38620,7 +38600,7 @@
         <p:spPr>
           <a:xfrm>
             <a:off x="5372100" y="3501390"/>
-            <a:ext cx="2911197" cy="323850"/>
+            <a:ext cx="10207330" cy="323850"/>
           </a:xfrm>
           <a:prstGeom prst="rect">
             <a:avLst/>
@@ -38673,7 +38653,7 @@
                 <a:ea typeface="Courier New" pitchFamily="34" charset="-122"/>
                 <a:cs typeface="Courier New" pitchFamily="34" charset="-120"/>
               </a:rPr>
-              <a:t>0,028</a:t>
+              <a:t>0,089</a:t>
             </a:r>
             <a:endParaRPr lang="en-US" sz="1500" dirty="0"/>
           </a:p>
@@ -38714,7 +38694,7 @@
                 <a:ea typeface="Courier New" pitchFamily="34" charset="-122"/>
                 <a:cs typeface="Courier New" pitchFamily="34" charset="-120"/>
               </a:rPr>
-              <a:t>custo_acum</a:t>
+              <a:t>idade_carreta</a:t>
             </a:r>
             <a:endParaRPr lang="en-US" sz="1650" dirty="0"/>
           </a:p>
@@ -38758,7 +38738,7 @@
         <p:spPr>
           <a:xfrm>
             <a:off x="5372100" y="3930015"/>
-            <a:ext cx="2857262" cy="323850"/>
+            <a:ext cx="5505077" cy="323850"/>
           </a:xfrm>
           <a:prstGeom prst="rect">
             <a:avLst/>
@@ -38811,7 +38791,7 @@
                 <a:ea typeface="Courier New" pitchFamily="34" charset="-122"/>
                 <a:cs typeface="Courier New" pitchFamily="34" charset="-120"/>
               </a:rPr>
-              <a:t>0,026</a:t>
+              <a:t>0,048</a:t>
             </a:r>
             <a:endParaRPr lang="en-US" sz="1500" dirty="0"/>
           </a:p>
@@ -38852,7 +38832,7 @@
                 <a:ea typeface="Courier New" pitchFamily="34" charset="-122"/>
                 <a:cs typeface="Courier New" pitchFamily="34" charset="-120"/>
               </a:rPr>
-              <a:t>km_rodado_ano</a:t>
+              <a:t>km_acumulado_defasado</a:t>
             </a:r>
             <a:endParaRPr lang="en-US" sz="1650" dirty="0"/>
           </a:p>
@@ -38896,13 +38876,13 @@
         <p:spPr>
           <a:xfrm>
             <a:off x="5372100" y="4358640"/>
-            <a:ext cx="2587705" cy="323850"/>
+            <a:ext cx="3555362" cy="323850"/>
           </a:xfrm>
           <a:prstGeom prst="rect">
             <a:avLst/>
           </a:prstGeom>
           <a:solidFill>
-            <a:srgbClr val="FFB65C"/>
+            <a:srgbClr val="2FA898"/>
           </a:solidFill>
           <a:ln/>
         </p:spPr>
@@ -38949,7 +38929,7 @@
                 <a:ea typeface="Courier New" pitchFamily="34" charset="-122"/>
                 <a:cs typeface="Courier New" pitchFamily="34" charset="-120"/>
               </a:rPr>
-              <a:t>0,025</a:t>
+              <a:t>0,031</a:t>
             </a:r>
             <a:endParaRPr lang="en-US" sz="1500" dirty="0"/>
           </a:p>
@@ -38990,7 +38970,7 @@
                 <a:ea typeface="Courier New" pitchFamily="34" charset="-122"/>
                 <a:cs typeface="Courier New" pitchFamily="34" charset="-120"/>
               </a:rPr>
-              <a:t>unit_subtype</a:t>
+              <a:t>comprimento</a:t>
             </a:r>
             <a:endParaRPr lang="en-US" sz="1650" dirty="0"/>
           </a:p>
@@ -39034,7 +39014,7 @@
         <p:spPr>
           <a:xfrm>
             <a:off x="5372100" y="4787265"/>
-            <a:ext cx="2102525" cy="323850"/>
+            <a:ext cx="2867227" cy="323850"/>
           </a:xfrm>
           <a:prstGeom prst="rect">
             <a:avLst/>
@@ -39128,7 +39108,7 @@
                 <a:ea typeface="Courier New" pitchFamily="34" charset="-122"/>
                 <a:cs typeface="Courier New" pitchFamily="34" charset="-120"/>
               </a:rPr>
-              <a:t>km_acumulado_fim_ano</a:t>
+              <a:t>n_os_ano_anterior</a:t>
             </a:r>
             <a:endParaRPr lang="en-US" sz="1650" dirty="0"/>
           </a:p>
@@ -39172,7 +39152,7 @@
         <p:spPr>
           <a:xfrm>
             <a:off x="5372100" y="5215890"/>
-            <a:ext cx="1789748" cy="323850"/>
+            <a:ext cx="2752538" cy="323850"/>
           </a:xfrm>
           <a:prstGeom prst="rect">
             <a:avLst/>
@@ -39225,7 +39205,7 @@
                 <a:ea typeface="Courier New" pitchFamily="34" charset="-122"/>
                 <a:cs typeface="Courier New" pitchFamily="34" charset="-120"/>
               </a:rPr>
-              <a:t>0,021</a:t>
+              <a:t>0,024</a:t>
             </a:r>
             <a:endParaRPr lang="en-US" sz="1500" dirty="0"/>
           </a:p>
@@ -39310,7 +39290,7 @@
         <p:spPr>
           <a:xfrm>
             <a:off x="5372100" y="5644515"/>
-            <a:ext cx="1272302" cy="323850"/>
+            <a:ext cx="2752538" cy="323850"/>
           </a:xfrm>
           <a:prstGeom prst="rect">
             <a:avLst/>
@@ -39363,7 +39343,7 @@
                 <a:ea typeface="Courier New" pitchFamily="34" charset="-122"/>
                 <a:cs typeface="Courier New" pitchFamily="34" charset="-120"/>
               </a:rPr>
-              <a:t>0,020</a:t>
+              <a:t>0,024</a:t>
             </a:r>
             <a:endParaRPr lang="en-US" sz="1500" dirty="0"/>
           </a:p>
@@ -39404,7 +39384,7 @@
                 <a:ea typeface="Courier New" pitchFamily="34" charset="-122"/>
                 <a:cs typeface="Courier New" pitchFamily="34" charset="-120"/>
               </a:rPr>
-              <a:t>idade_carreta</a:t>
+              <a:t>eixos</a:t>
             </a:r>
             <a:endParaRPr lang="en-US" sz="1650" dirty="0"/>
           </a:p>
@@ -39448,13 +39428,13 @@
         <p:spPr>
           <a:xfrm>
             <a:off x="5372100" y="6073140"/>
-            <a:ext cx="765453" cy="323850"/>
+            <a:ext cx="1835025" cy="323850"/>
           </a:xfrm>
           <a:prstGeom prst="rect">
             <a:avLst/>
           </a:prstGeom>
           <a:solidFill>
-            <a:srgbClr val="22525A"/>
+            <a:srgbClr val="2FA898"/>
           </a:solidFill>
           <a:ln/>
         </p:spPr>
@@ -39501,7 +39481,7 @@
                 <a:ea typeface="Courier New" pitchFamily="34" charset="-122"/>
                 <a:cs typeface="Courier New" pitchFamily="34" charset="-120"/>
               </a:rPr>
-              <a:t>0,009</a:t>
+              <a:t>0,016</a:t>
             </a:r>
             <a:endParaRPr lang="en-US" sz="1500" dirty="0"/>
           </a:p>
@@ -39542,7 +39522,7 @@
                 <a:ea typeface="Courier New" pitchFamily="34" charset="-122"/>
                 <a:cs typeface="Courier New" pitchFamily="34" charset="-120"/>
               </a:rPr>
-              <a:t>eixos</a:t>
+              <a:t>intervalo_medio_os_hist</a:t>
             </a:r>
             <a:endParaRPr lang="en-US" sz="1650" dirty="0"/>
           </a:p>
@@ -39586,13 +39566,13 @@
         <p:spPr>
           <a:xfrm>
             <a:off x="5372100" y="6501765"/>
-            <a:ext cx="711518" cy="323850"/>
+            <a:ext cx="1835025" cy="323850"/>
           </a:xfrm>
           <a:prstGeom prst="rect">
             <a:avLst/>
           </a:prstGeom>
           <a:solidFill>
-            <a:srgbClr val="22525A"/>
+            <a:srgbClr val="2FA898"/>
           </a:solidFill>
           <a:ln/>
         </p:spPr>
@@ -39639,7 +39619,7 @@
                 <a:ea typeface="Courier New" pitchFamily="34" charset="-122"/>
                 <a:cs typeface="Courier New" pitchFamily="34" charset="-120"/>
               </a:rPr>
-              <a:t>0,008</a:t>
+              <a:t>0,016</a:t>
             </a:r>
             <a:endParaRPr lang="en-US" sz="1500" dirty="0"/>
           </a:p>
@@ -39680,7 +39660,7 @@
                 <a:ea typeface="Courier New" pitchFamily="34" charset="-122"/>
                 <a:cs typeface="Courier New" pitchFamily="34" charset="-120"/>
               </a:rPr>
-              <a:t>suspension_type</a:t>
+              <a:t>tire_size</a:t>
             </a:r>
             <a:endParaRPr lang="en-US" sz="1650" dirty="0"/>
           </a:p>
@@ -39724,13 +39704,13 @@
         <p:spPr>
           <a:xfrm>
             <a:off x="5372100" y="6930390"/>
-            <a:ext cx="560665" cy="323850"/>
+            <a:ext cx="1605647" cy="323850"/>
           </a:xfrm>
           <a:prstGeom prst="rect">
             <a:avLst/>
           </a:prstGeom>
           <a:solidFill>
-            <a:srgbClr val="22525A"/>
+            <a:srgbClr val="2FA898"/>
           </a:solidFill>
           <a:ln/>
         </p:spPr>
@@ -39777,7 +39757,7 @@
                 <a:ea typeface="Courier New" pitchFamily="34" charset="-122"/>
                 <a:cs typeface="Courier New" pitchFamily="34" charset="-120"/>
               </a:rPr>
-              <a:t>0,007</a:t>
+              <a:t>0,014</a:t>
             </a:r>
             <a:endParaRPr lang="en-US" sz="1500" dirty="0"/>
           </a:p>
@@ -39850,7 +39830,7 @@
                 <a:ea typeface="Courier New" pitchFamily="34" charset="-122"/>
                 <a:cs typeface="Courier New" pitchFamily="34" charset="-120"/>
               </a:rPr>
-              <a:t>COMO LER Embaralhamos cada variável e medimos o quanto a previsão piora. A frequência de OS no ano domina; mesmo sem ela o modelo mantém R² 0,64 — histórico, uso e tipo de equipamento explicam o restante.</a:t>
+              <a:t>COMO LER Embaralhamos cada variável e medimos o quanto a previsão piora. No modelo preditivo, tipo da unidade e custo acumulado lideram; as variáveis do próprio ano ficam fora por vazamento.</a:t>
             </a:r>
             <a:r>
               <a:rPr lang="en-US" sz="1725" dirty="0">
@@ -40631,7 +40611,7 @@
                 <a:ea typeface="Courier New" pitchFamily="34" charset="-122"/>
                 <a:cs typeface="Courier New" pitchFamily="34" charset="-120"/>
               </a:rPr>
-              <a:t>SUPORTADA</a:t>
+              <a:t>PARCIAL</a:t>
             </a:r>
             <a:endParaRPr lang="en-US" sz="1425" dirty="0"/>
           </a:p>
@@ -40672,7 +40652,7 @@
                 <a:ea typeface="Arial" pitchFamily="34" charset="-122"/>
                 <a:cs typeface="Arial" pitchFamily="34" charset="-120"/>
               </a:rPr>
-              <a:t>km_rodado_ano ρ = +0,50 · exposição ao uso</a:t>
+              <a:t>uso do ano associa (ρ=+0,50), porém contemporâneo; km defasado entra no modelo</a:t>
             </a:r>
             <a:endParaRPr lang="en-US" sz="1575" dirty="0"/>
           </a:p>
@@ -40904,7 +40884,7 @@
                 <a:ea typeface="Arial" pitchFamily="34" charset="-122"/>
                 <a:cs typeface="Arial" pitchFamily="34" charset="-120"/>
               </a:rPr>
-              <a:t>n_os_ano +0,75 · custo_ano_anterior +0,53 · custo_acum +0,47</a:t>
+              <a:t>custo_ano_anterior +0,53 · custo_acum +0,47 · nº OS anterior — bloco preditivo mais forte</a:t>
             </a:r>
             <a:endParaRPr lang="en-US" sz="1575" dirty="0"/>
           </a:p>

</xml_diff>